<commit_message>
Finalize evaluated recovery workbench, deployed QA and complete presentation
</commit_message>
<xml_diff>
--- a/deliverables/granted-robotics-complete-presentation.pptx
+++ b/deliverables/granted-robotics-complete-presentation.pptx
@@ -2,24 +2,24 @@
 <file path=ppt/presentation.xml><?xml version="1.0" encoding="utf-8"?>
 <p:presentation xmlns:p="http://schemas.openxmlformats.org/presentationml/2006/main">
   <p:sldMasterIdLst>
-    <p:sldMasterId xmlns:r="http://schemas.openxmlformats.org/officeDocument/2006/relationships" id="2147483648" r:id="R8997cb25a2c84e34"/>
+    <p:sldMasterId xmlns:r="http://schemas.openxmlformats.org/officeDocument/2006/relationships" id="2147483648" r:id="R8ced6f8c2eed4b24"/>
   </p:sldMasterIdLst>
   <p:notesMasterIdLst>
-    <p:notesMasterId xmlns:r="http://schemas.openxmlformats.org/officeDocument/2006/relationships" r:id="Rb7088bb33324441b"/>
+    <p:notesMasterId xmlns:r="http://schemas.openxmlformats.org/officeDocument/2006/relationships" r:id="R7e54477d3e194919"/>
   </p:notesMasterIdLst>
   <p:sldIdLst>
-    <p:sldId xmlns:r="http://schemas.openxmlformats.org/officeDocument/2006/relationships" id="256" r:id="Rf1954afd5ee54f2f"/>
-    <p:sldId xmlns:r="http://schemas.openxmlformats.org/officeDocument/2006/relationships" id="257" r:id="Rd43bd5c34b8d4bdb"/>
-    <p:sldId xmlns:r="http://schemas.openxmlformats.org/officeDocument/2006/relationships" id="258" r:id="Ra386c915f6c74ace"/>
-    <p:sldId xmlns:r="http://schemas.openxmlformats.org/officeDocument/2006/relationships" id="259" r:id="R109d28e0cd374e97"/>
-    <p:sldId xmlns:r="http://schemas.openxmlformats.org/officeDocument/2006/relationships" id="260" r:id="R76f8d5f96f9840ba"/>
-    <p:sldId xmlns:r="http://schemas.openxmlformats.org/officeDocument/2006/relationships" id="261" r:id="R29c23f60550943e7"/>
-    <p:sldId xmlns:r="http://schemas.openxmlformats.org/officeDocument/2006/relationships" id="262" r:id="R073449f43e7f4b2c"/>
-    <p:sldId xmlns:r="http://schemas.openxmlformats.org/officeDocument/2006/relationships" id="263" r:id="R2f354b6526604255"/>
-    <p:sldId xmlns:r="http://schemas.openxmlformats.org/officeDocument/2006/relationships" id="264" r:id="R0c0e306d411f48a0"/>
-    <p:sldId xmlns:r="http://schemas.openxmlformats.org/officeDocument/2006/relationships" id="265" r:id="Rf9ad503a2f6a4551"/>
-    <p:sldId xmlns:r="http://schemas.openxmlformats.org/officeDocument/2006/relationships" id="266" r:id="Rb2c91a2be1674585"/>
-    <p:sldId xmlns:r="http://schemas.openxmlformats.org/officeDocument/2006/relationships" id="267" r:id="R1d6634b4ecdd437e"/>
+    <p:sldId xmlns:r="http://schemas.openxmlformats.org/officeDocument/2006/relationships" id="256" r:id="R1c43709b9a4d413a"/>
+    <p:sldId xmlns:r="http://schemas.openxmlformats.org/officeDocument/2006/relationships" id="257" r:id="R094d819b440641b2"/>
+    <p:sldId xmlns:r="http://schemas.openxmlformats.org/officeDocument/2006/relationships" id="258" r:id="R31f8b863e2fc4c3d"/>
+    <p:sldId xmlns:r="http://schemas.openxmlformats.org/officeDocument/2006/relationships" id="259" r:id="R9b62d08fbdd74165"/>
+    <p:sldId xmlns:r="http://schemas.openxmlformats.org/officeDocument/2006/relationships" id="260" r:id="R33a420af31d94a8b"/>
+    <p:sldId xmlns:r="http://schemas.openxmlformats.org/officeDocument/2006/relationships" id="261" r:id="Rd38fec859b4f4240"/>
+    <p:sldId xmlns:r="http://schemas.openxmlformats.org/officeDocument/2006/relationships" id="262" r:id="Re1a4801d5a0b4572"/>
+    <p:sldId xmlns:r="http://schemas.openxmlformats.org/officeDocument/2006/relationships" id="263" r:id="R8bf22a7a51d54462"/>
+    <p:sldId xmlns:r="http://schemas.openxmlformats.org/officeDocument/2006/relationships" id="264" r:id="R9145cc1b85a84b9b"/>
+    <p:sldId xmlns:r="http://schemas.openxmlformats.org/officeDocument/2006/relationships" id="265" r:id="R6009e6ed63b44f06"/>
+    <p:sldId xmlns:r="http://schemas.openxmlformats.org/officeDocument/2006/relationships" id="266" r:id="Rf4fc297a5f5c4440"/>
+    <p:sldId xmlns:r="http://schemas.openxmlformats.org/officeDocument/2006/relationships" id="267" r:id="R999d7969c5bb4e5e"/>
   </p:sldIdLst>
   <p:sldSz cx="12192000" cy="6858000"/>
   <p:notesSz cx="6858000" cy="9144000"/>
@@ -1153,7 +1153,7 @@
           <a:lstStyle xmlns:a="http://schemas.openxmlformats.org/drawingml/2006/main"/>
           <a:p xmlns:a="http://schemas.openxmlformats.org/drawingml/2006/main">
             <a:r>
-              <a:t>OpenVINO runs both the geometric graph and the learned joint target policy. In ten recovery trials, learned proposals plus correction reduced average numerical iterations by eight and a half percent. Both approaches completed every trial. The learned policy median inference was thirty seven microseconds on Apple hardware. Intel validation remains open.</a:t>
+              <a:t>OpenVINO runs both the geometric graph and the learned joint target policy. In ten recovery trials, learned proposals plus correction reduced average numerical iterations by five point three percent. Both approaches completed every trial. The learned policy median inference was thirty seven microseconds on Apple hardware. Intel validation remains open.</a:t>
             </a:r>
           </a:p>
         </p:txBody>
@@ -1291,7 +1291,7 @@
   </p:cSld>
   <p:clrMap bg1="lt1" tx1="dk1" bg2="lt2" tx2="dk2" accent1="accent1" accent2="accent2" accent3="accent3" accent4="accent4" accent5="accent5" accent6="accent6" hlink="hlink" folHlink="folHlink"/>
   <p:sldLayoutIdLst>
-    <p:sldLayoutId xmlns:r="http://schemas.openxmlformats.org/officeDocument/2006/relationships" id="2147483649" r:id="Rd9cdb1e9977e4939"/>
+    <p:sldLayoutId xmlns:r="http://schemas.openxmlformats.org/officeDocument/2006/relationships" id="2147483649" r:id="R0fe0d306205e4736"/>
   </p:sldLayoutIdLst>
   <p:txStyles>
     <p:titleStyle>
@@ -1859,10 +1859,10 @@
                 <c:formatCode>General</c:formatCode>
                 <c:ptCount val="2"/>
                 <c:pt idx="0">
-                  <c:v>13.81</c:v>
+                  <c:v>14.05</c:v>
                 </c:pt>
                 <c:pt idx="1">
-                  <c:v>160.87</c:v>
+                  <c:v>160.96</c:v>
                 </c:pt>
               </c:numCache>
             </c:numRef>
@@ -2015,7 +2015,7 @@
           <p:cNvPr id="6" name="">
             <a:extLst xmlns:a="http://schemas.openxmlformats.org/drawingml/2006/main">
               <a:ext uri="{FF2B5EF4-FFF2-40B4-BE49-F238E27FC236}">
-                <a16:creationId xmlns:a16="http://schemas.microsoft.com/office/drawing/2014/main" id="{F9781898-275C-4E73-836F-58AE0456A716}"/>
+                <a16:creationId xmlns:a16="http://schemas.microsoft.com/office/drawing/2014/main" id="{72967A19-C72E-4B44-9D51-1FABB6B0BEFF}"/>
               </a:ext>
             </a:extLst>
           </p:cNvPr>
@@ -2072,7 +2072,7 @@
           <p:cNvPr id="2" name="">
             <a:extLst xmlns:a="http://schemas.openxmlformats.org/drawingml/2006/main">
               <a:ext uri="{FF2B5EF4-FFF2-40B4-BE49-F238E27FC236}">
-                <a16:creationId xmlns:a16="http://schemas.microsoft.com/office/drawing/2014/main" id="{AB548350-0F6E-494F-831E-591C8463884F}"/>
+                <a16:creationId xmlns:a16="http://schemas.microsoft.com/office/drawing/2014/main" id="{3F167DDF-3720-4CF3-878A-586B1CB03728}"/>
               </a:ext>
             </a:extLst>
           </p:cNvPr>
@@ -2152,7 +2152,7 @@
           <p:cNvPr id="3" name="">
             <a:extLst xmlns:a="http://schemas.openxmlformats.org/drawingml/2006/main">
               <a:ext uri="{FF2B5EF4-FFF2-40B4-BE49-F238E27FC236}">
-                <a16:creationId xmlns:a16="http://schemas.microsoft.com/office/drawing/2014/main" id="{8F26378E-1F49-4CEE-8AA2-95B093EA6FFC}"/>
+                <a16:creationId xmlns:a16="http://schemas.microsoft.com/office/drawing/2014/main" id="{2F7E15A9-DE4F-48D0-ADF1-C3CE5333D093}"/>
               </a:ext>
             </a:extLst>
           </p:cNvPr>
@@ -2209,7 +2209,7 @@
           <p:cNvPr id="4" name="">
             <a:extLst xmlns:a="http://schemas.openxmlformats.org/drawingml/2006/main">
               <a:ext uri="{FF2B5EF4-FFF2-40B4-BE49-F238E27FC236}">
-                <a16:creationId xmlns:a16="http://schemas.microsoft.com/office/drawing/2014/main" id="{4619BC06-03D9-4D32-B3E5-1B5FF8E0B55C}"/>
+                <a16:creationId xmlns:a16="http://schemas.microsoft.com/office/drawing/2014/main" id="{CD55E0DB-A58D-4AEB-A119-503100C0C3B1}"/>
               </a:ext>
             </a:extLst>
           </p:cNvPr>
@@ -2266,7 +2266,7 @@
           <p:cNvPr id="5" name="">
             <a:extLst xmlns:a="http://schemas.openxmlformats.org/drawingml/2006/main">
               <a:ext uri="{FF2B5EF4-FFF2-40B4-BE49-F238E27FC236}">
-                <a16:creationId xmlns:a16="http://schemas.microsoft.com/office/drawing/2014/main" id="{D1004CAE-D46F-4614-82C9-7EE0F0CFEA9B}"/>
+                <a16:creationId xmlns:a16="http://schemas.microsoft.com/office/drawing/2014/main" id="{8AF20A2E-D031-435D-8292-D59A851A2957}"/>
               </a:ext>
             </a:extLst>
           </p:cNvPr>
@@ -2344,7 +2344,7 @@
     </p:spTree>
     <p:extLst>
       <p:ext uri="{BB962C8B-B14F-4D97-AF65-F5344CB8AC3E}">
-        <p14:creationId xmlns:p14="http://schemas.microsoft.com/office/powerpoint/2010/main" val="868836360"/>
+        <p14:creationId xmlns:p14="http://schemas.microsoft.com/office/powerpoint/2010/main" val="705582200"/>
       </p:ext>
     </p:extLst>
   </p:cSld>
@@ -2375,7 +2375,7 @@
           <p:cNvPr id="9" name="">
             <a:extLst xmlns:a="http://schemas.openxmlformats.org/drawingml/2006/main">
               <a:ext uri="{FF2B5EF4-FFF2-40B4-BE49-F238E27FC236}">
-                <a16:creationId xmlns:a16="http://schemas.microsoft.com/office/drawing/2014/main" id="{1F011416-137E-4B00-9927-E615210756B2}"/>
+                <a16:creationId xmlns:a16="http://schemas.microsoft.com/office/drawing/2014/main" id="{16B9195B-6D31-4F1D-9CFA-817EBFE281E3}"/>
               </a:ext>
             </a:extLst>
           </p:cNvPr>
@@ -2432,7 +2432,7 @@
           <p:cNvPr id="2" name="">
             <a:extLst xmlns:a="http://schemas.openxmlformats.org/drawingml/2006/main">
               <a:ext uri="{FF2B5EF4-FFF2-40B4-BE49-F238E27FC236}">
-                <a16:creationId xmlns:a16="http://schemas.microsoft.com/office/drawing/2014/main" id="{950FC6F6-060D-4AFB-9A97-29D3E204671F}"/>
+                <a16:creationId xmlns:a16="http://schemas.microsoft.com/office/drawing/2014/main" id="{29E37108-507A-4E6A-A9F6-4AAB45055C4F}"/>
               </a:ext>
             </a:extLst>
           </p:cNvPr>
@@ -2489,7 +2489,7 @@
           <p:cNvPr id="3" name="">
             <a:extLst xmlns:a="http://schemas.openxmlformats.org/drawingml/2006/main">
               <a:ext uri="{FF2B5EF4-FFF2-40B4-BE49-F238E27FC236}">
-                <a16:creationId xmlns:a16="http://schemas.microsoft.com/office/drawing/2014/main" id="{E35AB6CF-DAAF-4AA3-9D3E-DC0A2F128927}"/>
+                <a16:creationId xmlns:a16="http://schemas.microsoft.com/office/drawing/2014/main" id="{5D5FC161-CC2C-4755-B955-3744A9DFAB9F}"/>
               </a:ext>
             </a:extLst>
           </p:cNvPr>
@@ -2546,7 +2546,7 @@
           <p:cNvPr id="4" name="">
             <a:extLst xmlns:a="http://schemas.openxmlformats.org/drawingml/2006/main">
               <a:ext uri="{FF2B5EF4-FFF2-40B4-BE49-F238E27FC236}">
-                <a16:creationId xmlns:a16="http://schemas.microsoft.com/office/drawing/2014/main" id="{CA562DA4-0F1F-478C-8D40-200B960B7AD4}"/>
+                <a16:creationId xmlns:a16="http://schemas.microsoft.com/office/drawing/2014/main" id="{2886E9D7-B587-4C92-BF61-BB97D6048B08}"/>
               </a:ext>
             </a:extLst>
           </p:cNvPr>
@@ -2603,7 +2603,7 @@
           <p:cNvPr id="5" name="">
             <a:extLst xmlns:a="http://schemas.openxmlformats.org/drawingml/2006/main">
               <a:ext uri="{FF2B5EF4-FFF2-40B4-BE49-F238E27FC236}">
-                <a16:creationId xmlns:a16="http://schemas.microsoft.com/office/drawing/2014/main" id="{62EF9856-E0CD-4E41-8AEA-CD8C272F6EAE}"/>
+                <a16:creationId xmlns:a16="http://schemas.microsoft.com/office/drawing/2014/main" id="{38D7AC9B-082C-4F44-AE9F-C33A2E05D2F9}"/>
               </a:ext>
             </a:extLst>
           </p:cNvPr>
@@ -2729,7 +2729,7 @@
           <p:cNvPr id="6" name="">
             <a:extLst xmlns:a="http://schemas.openxmlformats.org/drawingml/2006/main">
               <a:ext uri="{FF2B5EF4-FFF2-40B4-BE49-F238E27FC236}">
-                <a16:creationId xmlns:a16="http://schemas.microsoft.com/office/drawing/2014/main" id="{F0FD361F-F3EE-41B3-A9E7-E224C1FE64A9}"/>
+                <a16:creationId xmlns:a16="http://schemas.microsoft.com/office/drawing/2014/main" id="{5969CB46-EA69-4D4F-8896-CC45F5D160C6}"/>
               </a:ext>
             </a:extLst>
           </p:cNvPr>
@@ -2786,7 +2786,7 @@
           <p:cNvPr id="7" name="">
             <a:extLst xmlns:a="http://schemas.openxmlformats.org/drawingml/2006/main">
               <a:ext uri="{FF2B5EF4-FFF2-40B4-BE49-F238E27FC236}">
-                <a16:creationId xmlns:a16="http://schemas.microsoft.com/office/drawing/2014/main" id="{9E36A0A5-BE41-45CD-964E-031A954C7430}"/>
+                <a16:creationId xmlns:a16="http://schemas.microsoft.com/office/drawing/2014/main" id="{4A206819-2D9E-41FE-914B-5859A23C064D}"/>
               </a:ext>
             </a:extLst>
           </p:cNvPr>
@@ -2894,7 +2894,7 @@
           <p:cNvPr id="8" name="">
             <a:extLst xmlns:a="http://schemas.openxmlformats.org/drawingml/2006/main">
               <a:ext uri="{FF2B5EF4-FFF2-40B4-BE49-F238E27FC236}">
-                <a16:creationId xmlns:a16="http://schemas.microsoft.com/office/drawing/2014/main" id="{190D0271-D93C-4F94-90F2-76A737FF1FF8}"/>
+                <a16:creationId xmlns:a16="http://schemas.microsoft.com/office/drawing/2014/main" id="{A8A4883B-BA5C-46E7-BAFD-55CD1F5C81F6}"/>
               </a:ext>
             </a:extLst>
           </p:cNvPr>
@@ -2949,7 +2949,7 @@
     </p:spTree>
     <p:extLst>
       <p:ext uri="{BB962C8B-B14F-4D97-AF65-F5344CB8AC3E}">
-        <p14:creationId xmlns:p14="http://schemas.microsoft.com/office/powerpoint/2010/main" val="29364877"/>
+        <p14:creationId xmlns:p14="http://schemas.microsoft.com/office/powerpoint/2010/main" val="826087044"/>
       </p:ext>
     </p:extLst>
   </p:cSld>
@@ -2980,7 +2980,7 @@
           <p:cNvPr id="6" name="">
             <a:extLst xmlns:a="http://schemas.openxmlformats.org/drawingml/2006/main">
               <a:ext uri="{FF2B5EF4-FFF2-40B4-BE49-F238E27FC236}">
-                <a16:creationId xmlns:a16="http://schemas.microsoft.com/office/drawing/2014/main" id="{BAE64D4C-941B-40A4-B25D-51F31A5A2C80}"/>
+                <a16:creationId xmlns:a16="http://schemas.microsoft.com/office/drawing/2014/main" id="{F767DC38-C78E-44B2-BDEA-171018DC1F5A}"/>
               </a:ext>
             </a:extLst>
           </p:cNvPr>
@@ -3037,7 +3037,7 @@
           <p:cNvPr id="2" name="">
             <a:extLst xmlns:a="http://schemas.openxmlformats.org/drawingml/2006/main">
               <a:ext uri="{FF2B5EF4-FFF2-40B4-BE49-F238E27FC236}">
-                <a16:creationId xmlns:a16="http://schemas.microsoft.com/office/drawing/2014/main" id="{F23F4CE5-F13E-4828-88EF-8DAD2C5C99EE}"/>
+                <a16:creationId xmlns:a16="http://schemas.microsoft.com/office/drawing/2014/main" id="{440777A3-0BAF-408D-AAC7-32B8D083223D}"/>
               </a:ext>
             </a:extLst>
           </p:cNvPr>
@@ -3094,7 +3094,7 @@
           <p:cNvPr id="3" name="">
             <a:extLst xmlns:a="http://schemas.openxmlformats.org/drawingml/2006/main">
               <a:ext uri="{FF2B5EF4-FFF2-40B4-BE49-F238E27FC236}">
-                <a16:creationId xmlns:a16="http://schemas.microsoft.com/office/drawing/2014/main" id="{1EE37727-5E55-4643-B2C7-097B7CD668B7}"/>
+                <a16:creationId xmlns:a16="http://schemas.microsoft.com/office/drawing/2014/main" id="{347A39D5-1848-4ED0-974F-9782739A980C}"/>
               </a:ext>
             </a:extLst>
           </p:cNvPr>
@@ -3329,7 +3329,7 @@
                           <a:ea typeface="Arial"/>
                           <a:cs typeface="Arial"/>
                         </a:rPr>
-                        <a:t>Small physics randomization</a:t>
+                        <a:t>Bounded proxy-object randomization</a:t>
                       </a:r>
                     </a:p>
                   </a:txBody>
@@ -3353,7 +3353,7 @@
                           <a:ea typeface="Arial"/>
                           <a:cs typeface="Arial"/>
                         </a:rPr>
-                        <a:t>Shape, lighting, background, and larger pose changes</a:t>
+                        <a:t>Novel objects, larger pose shifts, and held-out tasks</a:t>
                       </a:r>
                     </a:p>
                   </a:txBody>
@@ -3473,7 +3473,7 @@
           <p:cNvPr id="5" name="">
             <a:extLst xmlns:a="http://schemas.openxmlformats.org/drawingml/2006/main">
               <a:ext uri="{FF2B5EF4-FFF2-40B4-BE49-F238E27FC236}">
-                <a16:creationId xmlns:a16="http://schemas.microsoft.com/office/drawing/2014/main" id="{4DB8D8C0-F8DD-48B9-8713-F8F6FDA90190}"/>
+                <a16:creationId xmlns:a16="http://schemas.microsoft.com/office/drawing/2014/main" id="{79F2170B-3751-442A-A4F8-3670A6C3D966}"/>
               </a:ext>
             </a:extLst>
           </p:cNvPr>
@@ -3528,7 +3528,7 @@
     </p:spTree>
     <p:extLst>
       <p:ext uri="{BB962C8B-B14F-4D97-AF65-F5344CB8AC3E}">
-        <p14:creationId xmlns:p14="http://schemas.microsoft.com/office/powerpoint/2010/main" val="1024917557"/>
+        <p14:creationId xmlns:p14="http://schemas.microsoft.com/office/powerpoint/2010/main" val="1964998748"/>
       </p:ext>
     </p:extLst>
   </p:cSld>
@@ -3559,7 +3559,7 @@
           <p:cNvPr id="7" name="">
             <a:extLst xmlns:a="http://schemas.openxmlformats.org/drawingml/2006/main">
               <a:ext uri="{FF2B5EF4-FFF2-40B4-BE49-F238E27FC236}">
-                <a16:creationId xmlns:a16="http://schemas.microsoft.com/office/drawing/2014/main" id="{B1E2F303-0407-4FCB-9646-522A3E854621}"/>
+                <a16:creationId xmlns:a16="http://schemas.microsoft.com/office/drawing/2014/main" id="{EFC4447C-9627-4288-BBE2-14A7EDF3925C}"/>
               </a:ext>
             </a:extLst>
           </p:cNvPr>
@@ -3616,7 +3616,7 @@
           <p:cNvPr id="2" name="">
             <a:extLst xmlns:a="http://schemas.openxmlformats.org/drawingml/2006/main">
               <a:ext uri="{FF2B5EF4-FFF2-40B4-BE49-F238E27FC236}">
-                <a16:creationId xmlns:a16="http://schemas.microsoft.com/office/drawing/2014/main" id="{9594DA61-EAA0-49F9-8F78-122333CBB3BE}"/>
+                <a16:creationId xmlns:a16="http://schemas.microsoft.com/office/drawing/2014/main" id="{5345BED5-F3C2-43A9-A22E-B1DC9667A702}"/>
               </a:ext>
             </a:extLst>
           </p:cNvPr>
@@ -3696,7 +3696,7 @@
           <p:cNvPr id="3" name="">
             <a:extLst xmlns:a="http://schemas.openxmlformats.org/drawingml/2006/main">
               <a:ext uri="{FF2B5EF4-FFF2-40B4-BE49-F238E27FC236}">
-                <a16:creationId xmlns:a16="http://schemas.microsoft.com/office/drawing/2014/main" id="{6DFCCF66-4866-45A5-AB4E-759310106DA1}"/>
+                <a16:creationId xmlns:a16="http://schemas.microsoft.com/office/drawing/2014/main" id="{1C190C89-0AA1-4E41-AC1E-F4C16D62ADE5}"/>
               </a:ext>
             </a:extLst>
           </p:cNvPr>
@@ -3753,7 +3753,7 @@
           <p:cNvPr id="4" name="">
             <a:extLst xmlns:a="http://schemas.openxmlformats.org/drawingml/2006/main">
               <a:ext uri="{FF2B5EF4-FFF2-40B4-BE49-F238E27FC236}">
-                <a16:creationId xmlns:a16="http://schemas.microsoft.com/office/drawing/2014/main" id="{30B6DE51-5AA1-4CCC-9A27-77ABF5231842}"/>
+                <a16:creationId xmlns:a16="http://schemas.microsoft.com/office/drawing/2014/main" id="{3E1CC675-2BC3-4586-85B1-D260B7198F69}"/>
               </a:ext>
             </a:extLst>
           </p:cNvPr>
@@ -3810,7 +3810,7 @@
           <p:cNvPr id="5" name="">
             <a:extLst xmlns:a="http://schemas.openxmlformats.org/drawingml/2006/main">
               <a:ext uri="{FF2B5EF4-FFF2-40B4-BE49-F238E27FC236}">
-                <a16:creationId xmlns:a16="http://schemas.microsoft.com/office/drawing/2014/main" id="{D040D019-2770-48D8-8109-5A3025C60C02}"/>
+                <a16:creationId xmlns:a16="http://schemas.microsoft.com/office/drawing/2014/main" id="{8DD03A80-60B4-4842-A591-0E3D3E4AB467}"/>
               </a:ext>
             </a:extLst>
           </p:cNvPr>
@@ -3867,7 +3867,7 @@
           <p:cNvPr id="6" name="">
             <a:extLst xmlns:a="http://schemas.openxmlformats.org/drawingml/2006/main">
               <a:ext uri="{FF2B5EF4-FFF2-40B4-BE49-F238E27FC236}">
-                <a16:creationId xmlns:a16="http://schemas.microsoft.com/office/drawing/2014/main" id="{BE78D405-0F67-48EF-87BF-4C5412A81ADD}"/>
+                <a16:creationId xmlns:a16="http://schemas.microsoft.com/office/drawing/2014/main" id="{52F99692-0997-4B80-BD6B-6F6D935F6E48}"/>
               </a:ext>
             </a:extLst>
           </p:cNvPr>
@@ -3945,7 +3945,7 @@
     </p:spTree>
     <p:extLst>
       <p:ext uri="{BB962C8B-B14F-4D97-AF65-F5344CB8AC3E}">
-        <p14:creationId xmlns:p14="http://schemas.microsoft.com/office/powerpoint/2010/main" val="255189863"/>
+        <p14:creationId xmlns:p14="http://schemas.microsoft.com/office/powerpoint/2010/main" val="1060418549"/>
       </p:ext>
     </p:extLst>
   </p:cSld>
@@ -3976,7 +3976,7 @@
           <p:cNvPr id="9" name="">
             <a:extLst xmlns:a="http://schemas.openxmlformats.org/drawingml/2006/main">
               <a:ext uri="{FF2B5EF4-FFF2-40B4-BE49-F238E27FC236}">
-                <a16:creationId xmlns:a16="http://schemas.microsoft.com/office/drawing/2014/main" id="{BC9D636F-A93E-47E6-8F78-61069FA577CA}"/>
+                <a16:creationId xmlns:a16="http://schemas.microsoft.com/office/drawing/2014/main" id="{74AFD961-0030-444B-BB4C-0DB779C726C4}"/>
               </a:ext>
             </a:extLst>
           </p:cNvPr>
@@ -4033,7 +4033,7 @@
           <p:cNvPr id="2" name="">
             <a:extLst xmlns:a="http://schemas.openxmlformats.org/drawingml/2006/main">
               <a:ext uri="{FF2B5EF4-FFF2-40B4-BE49-F238E27FC236}">
-                <a16:creationId xmlns:a16="http://schemas.microsoft.com/office/drawing/2014/main" id="{14BCEC68-8CFD-495E-ABCC-A8A4556E1DDA}"/>
+                <a16:creationId xmlns:a16="http://schemas.microsoft.com/office/drawing/2014/main" id="{9E637F2C-F890-4F94-8CE6-1654A1E1C013}"/>
               </a:ext>
             </a:extLst>
           </p:cNvPr>
@@ -4090,7 +4090,7 @@
           <p:cNvPr id="3" name="">
             <a:extLst xmlns:a="http://schemas.openxmlformats.org/drawingml/2006/main">
               <a:ext uri="{FF2B5EF4-FFF2-40B4-BE49-F238E27FC236}">
-                <a16:creationId xmlns:a16="http://schemas.microsoft.com/office/drawing/2014/main" id="{40829C20-A6A8-4B9C-909C-3C55D4D1E7F1}"/>
+                <a16:creationId xmlns:a16="http://schemas.microsoft.com/office/drawing/2014/main" id="{59D02D09-60B0-4F9F-8832-D190A98DE3C2}"/>
               </a:ext>
             </a:extLst>
           </p:cNvPr>
@@ -4147,7 +4147,7 @@
           <p:cNvPr id="4" name="">
             <a:extLst xmlns:a="http://schemas.openxmlformats.org/drawingml/2006/main">
               <a:ext uri="{FF2B5EF4-FFF2-40B4-BE49-F238E27FC236}">
-                <a16:creationId xmlns:a16="http://schemas.microsoft.com/office/drawing/2014/main" id="{864091C3-40D9-49CE-93B4-40D17D529548}"/>
+                <a16:creationId xmlns:a16="http://schemas.microsoft.com/office/drawing/2014/main" id="{1A8F6298-F469-4090-8C48-39E4F1E09E04}"/>
               </a:ext>
             </a:extLst>
           </p:cNvPr>
@@ -4204,7 +4204,7 @@
           <p:cNvPr id="5" name="">
             <a:extLst xmlns:a="http://schemas.openxmlformats.org/drawingml/2006/main">
               <a:ext uri="{FF2B5EF4-FFF2-40B4-BE49-F238E27FC236}">
-                <a16:creationId xmlns:a16="http://schemas.microsoft.com/office/drawing/2014/main" id="{A9C706E1-90D4-43BF-9925-04575EB6C146}"/>
+                <a16:creationId xmlns:a16="http://schemas.microsoft.com/office/drawing/2014/main" id="{720F92EF-ACA0-477B-9694-0F43E72D2FD8}"/>
               </a:ext>
             </a:extLst>
           </p:cNvPr>
@@ -4307,7 +4307,7 @@
           <p:cNvPr id="6" name="">
             <a:extLst xmlns:a="http://schemas.openxmlformats.org/drawingml/2006/main">
               <a:ext uri="{FF2B5EF4-FFF2-40B4-BE49-F238E27FC236}">
-                <a16:creationId xmlns:a16="http://schemas.microsoft.com/office/drawing/2014/main" id="{C5B52188-081C-4CBC-A00D-53D15041D6C0}"/>
+                <a16:creationId xmlns:a16="http://schemas.microsoft.com/office/drawing/2014/main" id="{E1AA5FF2-A5DB-4EA5-AC86-958E5173823D}"/>
               </a:ext>
             </a:extLst>
           </p:cNvPr>
@@ -4364,7 +4364,7 @@
           <p:cNvPr id="7" name="">
             <a:extLst xmlns:a="http://schemas.openxmlformats.org/drawingml/2006/main">
               <a:ext uri="{FF2B5EF4-FFF2-40B4-BE49-F238E27FC236}">
-                <a16:creationId xmlns:a16="http://schemas.microsoft.com/office/drawing/2014/main" id="{92F2C03B-23E4-439D-89BD-F19E39DA5778}"/>
+                <a16:creationId xmlns:a16="http://schemas.microsoft.com/office/drawing/2014/main" id="{2C4366D5-F957-4A0E-A08E-E406C822BEE5}"/>
               </a:ext>
             </a:extLst>
           </p:cNvPr>
@@ -4467,7 +4467,7 @@
           <p:cNvPr id="8" name="">
             <a:extLst xmlns:a="http://schemas.openxmlformats.org/drawingml/2006/main">
               <a:ext uri="{FF2B5EF4-FFF2-40B4-BE49-F238E27FC236}">
-                <a16:creationId xmlns:a16="http://schemas.microsoft.com/office/drawing/2014/main" id="{952AED79-EB98-448F-8C4D-EDBCA4520A24}"/>
+                <a16:creationId xmlns:a16="http://schemas.microsoft.com/office/drawing/2014/main" id="{87DDE6FA-A10A-4C04-BE90-D00A4C6A9DAB}"/>
               </a:ext>
             </a:extLst>
           </p:cNvPr>
@@ -4522,7 +4522,7 @@
     </p:spTree>
     <p:extLst>
       <p:ext uri="{BB962C8B-B14F-4D97-AF65-F5344CB8AC3E}">
-        <p14:creationId xmlns:p14="http://schemas.microsoft.com/office/powerpoint/2010/main" val="1926568479"/>
+        <p14:creationId xmlns:p14="http://schemas.microsoft.com/office/powerpoint/2010/main" val="1257445813"/>
       </p:ext>
     </p:extLst>
   </p:cSld>
@@ -4553,7 +4553,7 @@
           <p:cNvPr id="6" name="">
             <a:extLst xmlns:a="http://schemas.openxmlformats.org/drawingml/2006/main">
               <a:ext uri="{FF2B5EF4-FFF2-40B4-BE49-F238E27FC236}">
-                <a16:creationId xmlns:a16="http://schemas.microsoft.com/office/drawing/2014/main" id="{40D533D7-A48E-443E-B3EC-F16936533842}"/>
+                <a16:creationId xmlns:a16="http://schemas.microsoft.com/office/drawing/2014/main" id="{76816E95-E985-430F-97D3-284D97C6D318}"/>
               </a:ext>
             </a:extLst>
           </p:cNvPr>
@@ -4610,7 +4610,7 @@
           <p:cNvPr id="2" name="">
             <a:extLst xmlns:a="http://schemas.openxmlformats.org/drawingml/2006/main">
               <a:ext uri="{FF2B5EF4-FFF2-40B4-BE49-F238E27FC236}">
-                <a16:creationId xmlns:a16="http://schemas.microsoft.com/office/drawing/2014/main" id="{B2A0BFA6-84B5-4F34-8E2D-45D8B626E8E1}"/>
+                <a16:creationId xmlns:a16="http://schemas.microsoft.com/office/drawing/2014/main" id="{CFAA234D-5E57-4CE0-9545-C995D73A9695}"/>
               </a:ext>
             </a:extLst>
           </p:cNvPr>
@@ -4667,7 +4667,7 @@
           <p:cNvPr id="3" name="">
             <a:extLst xmlns:a="http://schemas.openxmlformats.org/drawingml/2006/main">
               <a:ext uri="{FF2B5EF4-FFF2-40B4-BE49-F238E27FC236}">
-                <a16:creationId xmlns:a16="http://schemas.microsoft.com/office/drawing/2014/main" id="{570C046B-D611-4FEB-9F99-57CBA4120233}"/>
+                <a16:creationId xmlns:a16="http://schemas.microsoft.com/office/drawing/2014/main" id="{209988EA-2C43-4586-96F6-DC7E5D906E97}"/>
               </a:ext>
             </a:extLst>
           </p:cNvPr>
@@ -5046,7 +5046,7 @@
           <p:cNvPr id="5" name="">
             <a:extLst xmlns:a="http://schemas.openxmlformats.org/drawingml/2006/main">
               <a:ext uri="{FF2B5EF4-FFF2-40B4-BE49-F238E27FC236}">
-                <a16:creationId xmlns:a16="http://schemas.microsoft.com/office/drawing/2014/main" id="{2B2190F0-84E6-4B42-A102-E3785B76B159}"/>
+                <a16:creationId xmlns:a16="http://schemas.microsoft.com/office/drawing/2014/main" id="{C81C148C-ABA6-4C56-8BAB-C1FF0FA59E09}"/>
               </a:ext>
             </a:extLst>
           </p:cNvPr>
@@ -5101,7 +5101,7 @@
     </p:spTree>
     <p:extLst>
       <p:ext uri="{BB962C8B-B14F-4D97-AF65-F5344CB8AC3E}">
-        <p14:creationId xmlns:p14="http://schemas.microsoft.com/office/powerpoint/2010/main" val="1559521851"/>
+        <p14:creationId xmlns:p14="http://schemas.microsoft.com/office/powerpoint/2010/main" val="168035029"/>
       </p:ext>
     </p:extLst>
   </p:cSld>
@@ -5132,7 +5132,7 @@
           <p:cNvPr id="10" name="">
             <a:extLst xmlns:a="http://schemas.openxmlformats.org/drawingml/2006/main">
               <a:ext uri="{FF2B5EF4-FFF2-40B4-BE49-F238E27FC236}">
-                <a16:creationId xmlns:a16="http://schemas.microsoft.com/office/drawing/2014/main" id="{1B71609D-9583-4956-B3EC-185FA115E87E}"/>
+                <a16:creationId xmlns:a16="http://schemas.microsoft.com/office/drawing/2014/main" id="{D0BDB6D9-D76C-41A4-8C86-21C08038B454}"/>
               </a:ext>
             </a:extLst>
           </p:cNvPr>
@@ -5189,7 +5189,7 @@
           <p:cNvPr id="2" name="">
             <a:extLst xmlns:a="http://schemas.openxmlformats.org/drawingml/2006/main">
               <a:ext uri="{FF2B5EF4-FFF2-40B4-BE49-F238E27FC236}">
-                <a16:creationId xmlns:a16="http://schemas.microsoft.com/office/drawing/2014/main" id="{7E779094-D9CD-418E-9779-FCFD40AA19E4}"/>
+                <a16:creationId xmlns:a16="http://schemas.microsoft.com/office/drawing/2014/main" id="{70E218AF-BDBA-4EAB-A692-33F7057CC26F}"/>
               </a:ext>
             </a:extLst>
           </p:cNvPr>
@@ -5246,7 +5246,7 @@
           <p:cNvPr id="3" name="">
             <a:extLst xmlns:a="http://schemas.openxmlformats.org/drawingml/2006/main">
               <a:ext uri="{FF2B5EF4-FFF2-40B4-BE49-F238E27FC236}">
-                <a16:creationId xmlns:a16="http://schemas.microsoft.com/office/drawing/2014/main" id="{3FF5D508-3D26-4DAA-8CDD-2B5B7E920C84}"/>
+                <a16:creationId xmlns:a16="http://schemas.microsoft.com/office/drawing/2014/main" id="{2A3EEE3D-5CF2-48CA-8631-109D13E87673}"/>
               </a:ext>
             </a:extLst>
           </p:cNvPr>
@@ -5307,7 +5307,7 @@
           <p:nvPr/>
         </p:nvPicPr>
         <p:blipFill>
-          <a:blip xmlns:r="http://schemas.openxmlformats.org/officeDocument/2006/relationships" xmlns:a="http://schemas.openxmlformats.org/drawingml/2006/main" r:embed="Rc72f4af53432493c"/>
+          <a:blip xmlns:r="http://schemas.openxmlformats.org/officeDocument/2006/relationships" xmlns:a="http://schemas.openxmlformats.org/drawingml/2006/main" r:embed="Ree1c3f260eec48c7"/>
           <a:stretch xmlns:a="http://schemas.openxmlformats.org/drawingml/2006/main"/>
         </p:blipFill>
         <p:spPr>
@@ -5325,7 +5325,7 @@
           <p:cNvPr id="5" name="">
             <a:extLst xmlns:a="http://schemas.openxmlformats.org/drawingml/2006/main">
               <a:ext uri="{FF2B5EF4-FFF2-40B4-BE49-F238E27FC236}">
-                <a16:creationId xmlns:a16="http://schemas.microsoft.com/office/drawing/2014/main" id="{DA5F93AD-214F-45E5-92C2-DE701602FCF8}"/>
+                <a16:creationId xmlns:a16="http://schemas.microsoft.com/office/drawing/2014/main" id="{FA24E7E9-1503-45D7-ABE2-0DB3E0C4944C}"/>
               </a:ext>
             </a:extLst>
           </p:cNvPr>
@@ -5382,7 +5382,7 @@
           <p:cNvPr id="6" name="">
             <a:extLst xmlns:a="http://schemas.openxmlformats.org/drawingml/2006/main">
               <a:ext uri="{FF2B5EF4-FFF2-40B4-BE49-F238E27FC236}">
-                <a16:creationId xmlns:a16="http://schemas.microsoft.com/office/drawing/2014/main" id="{9D496616-4A8F-444F-9183-AB0C898C7F10}"/>
+                <a16:creationId xmlns:a16="http://schemas.microsoft.com/office/drawing/2014/main" id="{1F5C9131-A5CE-4831-A94A-2B37392B8CA2}"/>
               </a:ext>
             </a:extLst>
           </p:cNvPr>
@@ -5439,7 +5439,7 @@
           <p:cNvPr id="7" name="">
             <a:extLst xmlns:a="http://schemas.openxmlformats.org/drawingml/2006/main">
               <a:ext uri="{FF2B5EF4-FFF2-40B4-BE49-F238E27FC236}">
-                <a16:creationId xmlns:a16="http://schemas.microsoft.com/office/drawing/2014/main" id="{F8C700FA-5415-4579-80BA-7946FC6A97B6}"/>
+                <a16:creationId xmlns:a16="http://schemas.microsoft.com/office/drawing/2014/main" id="{73E0BBCC-3D95-4B88-BC14-94941B77D749}"/>
               </a:ext>
             </a:extLst>
           </p:cNvPr>
@@ -5496,7 +5496,7 @@
           <p:cNvPr id="8" name="">
             <a:extLst xmlns:a="http://schemas.openxmlformats.org/drawingml/2006/main">
               <a:ext uri="{FF2B5EF4-FFF2-40B4-BE49-F238E27FC236}">
-                <a16:creationId xmlns:a16="http://schemas.microsoft.com/office/drawing/2014/main" id="{3246E4D4-050A-4119-A8C9-C0EEC257391D}"/>
+                <a16:creationId xmlns:a16="http://schemas.microsoft.com/office/drawing/2014/main" id="{5C2B8361-2C7F-43D4-BCCA-89AF39712F42}"/>
               </a:ext>
             </a:extLst>
           </p:cNvPr>
@@ -5599,7 +5599,7 @@
           <p:cNvPr id="9" name="">
             <a:extLst xmlns:a="http://schemas.openxmlformats.org/drawingml/2006/main">
               <a:ext uri="{FF2B5EF4-FFF2-40B4-BE49-F238E27FC236}">
-                <a16:creationId xmlns:a16="http://schemas.microsoft.com/office/drawing/2014/main" id="{A5C38F5F-F95E-4C92-82FF-1A9D2F59E245}"/>
+                <a16:creationId xmlns:a16="http://schemas.microsoft.com/office/drawing/2014/main" id="{7B11C189-B0AC-41CE-9B82-7D0D41636142}"/>
               </a:ext>
             </a:extLst>
           </p:cNvPr>
@@ -5654,7 +5654,7 @@
     </p:spTree>
     <p:extLst>
       <p:ext uri="{BB962C8B-B14F-4D97-AF65-F5344CB8AC3E}">
-        <p14:creationId xmlns:p14="http://schemas.microsoft.com/office/powerpoint/2010/main" val="1279040195"/>
+        <p14:creationId xmlns:p14="http://schemas.microsoft.com/office/powerpoint/2010/main" val="901174762"/>
       </p:ext>
     </p:extLst>
   </p:cSld>
@@ -5685,7 +5685,7 @@
           <p:cNvPr id="7" name="">
             <a:extLst xmlns:a="http://schemas.openxmlformats.org/drawingml/2006/main">
               <a:ext uri="{FF2B5EF4-FFF2-40B4-BE49-F238E27FC236}">
-                <a16:creationId xmlns:a16="http://schemas.microsoft.com/office/drawing/2014/main" id="{32B4FA43-C181-4EBC-8219-A3BC5EBED771}"/>
+                <a16:creationId xmlns:a16="http://schemas.microsoft.com/office/drawing/2014/main" id="{6A53F9F2-1E13-4AA5-A281-A9D0C5025E33}"/>
               </a:ext>
             </a:extLst>
           </p:cNvPr>
@@ -5742,7 +5742,7 @@
           <p:cNvPr id="2" name="">
             <a:extLst xmlns:a="http://schemas.openxmlformats.org/drawingml/2006/main">
               <a:ext uri="{FF2B5EF4-FFF2-40B4-BE49-F238E27FC236}">
-                <a16:creationId xmlns:a16="http://schemas.microsoft.com/office/drawing/2014/main" id="{86756369-E0EB-44B6-AA07-F3E7FFA6C6A3}"/>
+                <a16:creationId xmlns:a16="http://schemas.microsoft.com/office/drawing/2014/main" id="{360588CE-4E22-4834-A8FD-CA1483F7D062}"/>
               </a:ext>
             </a:extLst>
           </p:cNvPr>
@@ -5799,7 +5799,7 @@
           <p:cNvPr id="3" name="">
             <a:extLst xmlns:a="http://schemas.openxmlformats.org/drawingml/2006/main">
               <a:ext uri="{FF2B5EF4-FFF2-40B4-BE49-F238E27FC236}">
-                <a16:creationId xmlns:a16="http://schemas.microsoft.com/office/drawing/2014/main" id="{C0E69EC3-C359-4E67-AAD9-A6323559B038}"/>
+                <a16:creationId xmlns:a16="http://schemas.microsoft.com/office/drawing/2014/main" id="{3D0A41A7-B587-4271-85AF-55BEAA294BCA}"/>
               </a:ext>
             </a:extLst>
           </p:cNvPr>
@@ -5860,7 +5860,7 @@
           <p:nvPr/>
         </p:nvPicPr>
         <p:blipFill>
-          <a:blip xmlns:r="http://schemas.openxmlformats.org/officeDocument/2006/relationships" xmlns:a="http://schemas.openxmlformats.org/drawingml/2006/main" r:embed="R001f24714f9b4ef9"/>
+          <a:blip xmlns:r="http://schemas.openxmlformats.org/officeDocument/2006/relationships" xmlns:a="http://schemas.openxmlformats.org/drawingml/2006/main" r:embed="Rfe59bf66e5664d42"/>
           <a:stretch xmlns:a="http://schemas.openxmlformats.org/drawingml/2006/main"/>
         </p:blipFill>
         <p:spPr>
@@ -5878,7 +5878,7 @@
           <p:cNvPr id="5" name="">
             <a:extLst xmlns:a="http://schemas.openxmlformats.org/drawingml/2006/main">
               <a:ext uri="{FF2B5EF4-FFF2-40B4-BE49-F238E27FC236}">
-                <a16:creationId xmlns:a16="http://schemas.microsoft.com/office/drawing/2014/main" id="{5F59869F-97A0-4276-9C1D-98E41C9BAB49}"/>
+                <a16:creationId xmlns:a16="http://schemas.microsoft.com/office/drawing/2014/main" id="{AB1BF916-2B1D-4211-8AC4-DD9248484551}"/>
               </a:ext>
             </a:extLst>
           </p:cNvPr>
@@ -6009,7 +6009,7 @@
           <p:cNvPr id="6" name="">
             <a:extLst xmlns:a="http://schemas.openxmlformats.org/drawingml/2006/main">
               <a:ext uri="{FF2B5EF4-FFF2-40B4-BE49-F238E27FC236}">
-                <a16:creationId xmlns:a16="http://schemas.microsoft.com/office/drawing/2014/main" id="{43A16080-9244-4F7A-9D34-C338EEE3E03B}"/>
+                <a16:creationId xmlns:a16="http://schemas.microsoft.com/office/drawing/2014/main" id="{BBAB8E51-2AE5-460C-86BB-61C60B785987}"/>
               </a:ext>
             </a:extLst>
           </p:cNvPr>
@@ -6064,7 +6064,7 @@
     </p:spTree>
     <p:extLst>
       <p:ext uri="{BB962C8B-B14F-4D97-AF65-F5344CB8AC3E}">
-        <p14:creationId xmlns:p14="http://schemas.microsoft.com/office/powerpoint/2010/main" val="1191444655"/>
+        <p14:creationId xmlns:p14="http://schemas.microsoft.com/office/powerpoint/2010/main" val="954865934"/>
       </p:ext>
     </p:extLst>
   </p:cSld>
@@ -6095,7 +6095,7 @@
           <p:cNvPr id="6" name="">
             <a:extLst xmlns:a="http://schemas.openxmlformats.org/drawingml/2006/main">
               <a:ext uri="{FF2B5EF4-FFF2-40B4-BE49-F238E27FC236}">
-                <a16:creationId xmlns:a16="http://schemas.microsoft.com/office/drawing/2014/main" id="{FC8CAED9-C04D-40E7-AB7E-A1AAAEFB411E}"/>
+                <a16:creationId xmlns:a16="http://schemas.microsoft.com/office/drawing/2014/main" id="{B939E7CB-3C42-40A2-A241-9E95D494446C}"/>
               </a:ext>
             </a:extLst>
           </p:cNvPr>
@@ -6152,7 +6152,7 @@
           <p:cNvPr id="2" name="">
             <a:extLst xmlns:a="http://schemas.openxmlformats.org/drawingml/2006/main">
               <a:ext uri="{FF2B5EF4-FFF2-40B4-BE49-F238E27FC236}">
-                <a16:creationId xmlns:a16="http://schemas.microsoft.com/office/drawing/2014/main" id="{528D36A1-14C3-439F-B09D-D83452BAEAC6}"/>
+                <a16:creationId xmlns:a16="http://schemas.microsoft.com/office/drawing/2014/main" id="{9116C952-EC02-479D-B2F1-7E0EE7235565}"/>
               </a:ext>
             </a:extLst>
           </p:cNvPr>
@@ -6209,7 +6209,7 @@
           <p:cNvPr id="3" name="">
             <a:extLst xmlns:a="http://schemas.openxmlformats.org/drawingml/2006/main">
               <a:ext uri="{FF2B5EF4-FFF2-40B4-BE49-F238E27FC236}">
-                <a16:creationId xmlns:a16="http://schemas.microsoft.com/office/drawing/2014/main" id="{07FE247C-02A6-4BF7-A653-6A4ED872F9D4}"/>
+                <a16:creationId xmlns:a16="http://schemas.microsoft.com/office/drawing/2014/main" id="{F0F47E61-3C21-4083-984E-BA4BB450FD52}"/>
               </a:ext>
             </a:extLst>
           </p:cNvPr>
@@ -6466,7 +6466,7 @@
                           <a:ea typeface="Arial"/>
                           <a:cs typeface="Arial"/>
                         </a:rPr>
-                        <a:t>15.66 mm</a:t>
+                        <a:t>15.71 mm</a:t>
                       </a:r>
                     </a:p>
                   </a:txBody>
@@ -6564,7 +6564,7 @@
                           <a:ea typeface="Arial"/>
                           <a:cs typeface="Arial"/>
                         </a:rPr>
-                        <a:t>9.12 mm</a:t>
+                        <a:t>9.09 mm</a:t>
                       </a:r>
                     </a:p>
                   </a:txBody>
@@ -6662,7 +6662,7 @@
                           <a:ea typeface="Arial"/>
                           <a:cs typeface="Arial"/>
                         </a:rPr>
-                        <a:t>13.81 mm</a:t>
+                        <a:t>14.05 mm</a:t>
                       </a:r>
                     </a:p>
                   </a:txBody>
@@ -6760,7 +6760,7 @@
                           <a:ea typeface="Arial"/>
                           <a:cs typeface="Arial"/>
                         </a:rPr>
-                        <a:t>160.87 mm</a:t>
+                        <a:t>160.96 mm</a:t>
                       </a:r>
                     </a:p>
                   </a:txBody>
@@ -6878,7 +6878,7 @@
           <p:cNvPr id="5" name="">
             <a:extLst xmlns:a="http://schemas.openxmlformats.org/drawingml/2006/main">
               <a:ext uri="{FF2B5EF4-FFF2-40B4-BE49-F238E27FC236}">
-                <a16:creationId xmlns:a16="http://schemas.microsoft.com/office/drawing/2014/main" id="{540CEDD0-BC4E-4C4C-A884-3F023BA32254}"/>
+                <a16:creationId xmlns:a16="http://schemas.microsoft.com/office/drawing/2014/main" id="{5692456F-7A48-4FA8-894F-E0AE8D468B83}"/>
               </a:ext>
             </a:extLst>
           </p:cNvPr>
@@ -6925,7 +6925,7 @@
                 <a:ea typeface="Arial"/>
                 <a:cs typeface="Arial"/>
               </a:rPr>
-              <a:t>Each seed varies object XY by +/-8 mm, mass and sliding friction by 0.8x to 1.2x.</a:t>
+              <a:t>Randomized XY, mass, friction, cylinder size, lighting, and table color.</a:t>
             </a:r>
           </a:p>
         </p:txBody>
@@ -6933,7 +6933,7 @@
     </p:spTree>
     <p:extLst>
       <p:ext uri="{BB962C8B-B14F-4D97-AF65-F5344CB8AC3E}">
-        <p14:creationId xmlns:p14="http://schemas.microsoft.com/office/powerpoint/2010/main" val="1222337415"/>
+        <p14:creationId xmlns:p14="http://schemas.microsoft.com/office/powerpoint/2010/main" val="960423784"/>
       </p:ext>
     </p:extLst>
   </p:cSld>
@@ -6964,7 +6964,7 @@
           <p:cNvPr id="8" name="">
             <a:extLst xmlns:a="http://schemas.openxmlformats.org/drawingml/2006/main">
               <a:ext uri="{FF2B5EF4-FFF2-40B4-BE49-F238E27FC236}">
-                <a16:creationId xmlns:a16="http://schemas.microsoft.com/office/drawing/2014/main" id="{A57A5E30-4692-4411-9985-C229F512322E}"/>
+                <a16:creationId xmlns:a16="http://schemas.microsoft.com/office/drawing/2014/main" id="{9F986275-3ADB-4132-9BDD-987998E0A791}"/>
               </a:ext>
             </a:extLst>
           </p:cNvPr>
@@ -7021,7 +7021,7 @@
           <p:cNvPr id="2" name="">
             <a:extLst xmlns:a="http://schemas.openxmlformats.org/drawingml/2006/main">
               <a:ext uri="{FF2B5EF4-FFF2-40B4-BE49-F238E27FC236}">
-                <a16:creationId xmlns:a16="http://schemas.microsoft.com/office/drawing/2014/main" id="{94C9CDA8-2E4C-42D2-BE20-49B61389D7E1}"/>
+                <a16:creationId xmlns:a16="http://schemas.microsoft.com/office/drawing/2014/main" id="{A0E258CF-F13A-4286-8771-7AF896FCEA8A}"/>
               </a:ext>
             </a:extLst>
           </p:cNvPr>
@@ -7078,7 +7078,7 @@
           <p:cNvPr id="3" name="">
             <a:extLst xmlns:a="http://schemas.openxmlformats.org/drawingml/2006/main">
               <a:ext uri="{FF2B5EF4-FFF2-40B4-BE49-F238E27FC236}">
-                <a16:creationId xmlns:a16="http://schemas.microsoft.com/office/drawing/2014/main" id="{A6CAF254-609E-462F-A921-578DF1983D82}"/>
+                <a16:creationId xmlns:a16="http://schemas.microsoft.com/office/drawing/2014/main" id="{9E9532F5-5E82-4F36-8606-71A87BE14B4C}"/>
               </a:ext>
             </a:extLst>
           </p:cNvPr>
@@ -7262,7 +7262,7 @@
                           <a:ea typeface="Arial"/>
                           <a:cs typeface="Arial"/>
                         </a:rPr>
-                        <a:t>13.52 mm</a:t>
+                        <a:t>15.11 mm</a:t>
                       </a:r>
                     </a:p>
                   </a:txBody>
@@ -7286,7 +7286,7 @@
                           <a:ea typeface="Arial"/>
                           <a:cs typeface="Arial"/>
                         </a:rPr>
-                        <a:t>13.30 mm</a:t>
+                        <a:t>13.16 mm</a:t>
                       </a:r>
                     </a:p>
                   </a:txBody>
@@ -7336,7 +7336,7 @@
                           <a:ea typeface="Arial"/>
                           <a:cs typeface="Arial"/>
                         </a:rPr>
-                        <a:t>14.27 mm</a:t>
+                        <a:t>12.73 mm</a:t>
                       </a:r>
                     </a:p>
                   </a:txBody>
@@ -7360,7 +7360,7 @@
                           <a:ea typeface="Arial"/>
                           <a:cs typeface="Arial"/>
                         </a:rPr>
-                        <a:t>12.92 mm</a:t>
+                        <a:t>12.56 mm</a:t>
                       </a:r>
                     </a:p>
                   </a:txBody>
@@ -7410,7 +7410,7 @@
                           <a:ea typeface="Arial"/>
                           <a:cs typeface="Arial"/>
                         </a:rPr>
-                        <a:t>14.94 mm</a:t>
+                        <a:t>15.67 mm</a:t>
                       </a:r>
                     </a:p>
                   </a:txBody>
@@ -7434,7 +7434,7 @@
                           <a:ea typeface="Arial"/>
                           <a:cs typeface="Arial"/>
                         </a:rPr>
-                        <a:t>13.12 mm</a:t>
+                        <a:t>12.62 mm</a:t>
                       </a:r>
                     </a:p>
                   </a:txBody>
@@ -7484,7 +7484,7 @@
                           <a:ea typeface="Arial"/>
                           <a:cs typeface="Arial"/>
                         </a:rPr>
-                        <a:t>15.10 mm</a:t>
+                        <a:t>15.09 mm</a:t>
                       </a:r>
                     </a:p>
                   </a:txBody>
@@ -7508,7 +7508,7 @@
                           <a:ea typeface="Arial"/>
                           <a:cs typeface="Arial"/>
                         </a:rPr>
-                        <a:t>13.01 mm</a:t>
+                        <a:t>12.67 mm</a:t>
                       </a:r>
                     </a:p>
                   </a:txBody>
@@ -7558,7 +7558,7 @@
                           <a:ea typeface="Arial"/>
                           <a:cs typeface="Arial"/>
                         </a:rPr>
-                        <a:t>12.98 mm</a:t>
+                        <a:t>12.81 mm</a:t>
                       </a:r>
                     </a:p>
                   </a:txBody>
@@ -7582,7 +7582,7 @@
                           <a:ea typeface="Arial"/>
                           <a:cs typeface="Arial"/>
                         </a:rPr>
-                        <a:t>12.76 mm</a:t>
+                        <a:t>12.26 mm</a:t>
                       </a:r>
                     </a:p>
                   </a:txBody>
@@ -7632,7 +7632,7 @@
                           <a:ea typeface="Arial"/>
                           <a:cs typeface="Arial"/>
                         </a:rPr>
-                        <a:t>12.91 mm</a:t>
+                        <a:t>12.53 mm</a:t>
                       </a:r>
                     </a:p>
                   </a:txBody>
@@ -7656,7 +7656,7 @@
                           <a:ea typeface="Arial"/>
                           <a:cs typeface="Arial"/>
                         </a:rPr>
-                        <a:t>12.96 mm</a:t>
+                        <a:t>12.72 mm</a:t>
                       </a:r>
                     </a:p>
                   </a:txBody>
@@ -7706,7 +7706,7 @@
                           <a:ea typeface="Arial"/>
                           <a:cs typeface="Arial"/>
                         </a:rPr>
-                        <a:t>13.88 mm</a:t>
+                        <a:t>16.68 mm</a:t>
                       </a:r>
                     </a:p>
                   </a:txBody>
@@ -7730,7 +7730,7 @@
                           <a:ea typeface="Arial"/>
                           <a:cs typeface="Arial"/>
                         </a:rPr>
-                        <a:t>12.85 mm</a:t>
+                        <a:t>12.97 mm</a:t>
                       </a:r>
                     </a:p>
                   </a:txBody>
@@ -7780,7 +7780,7 @@
                           <a:ea typeface="Arial"/>
                           <a:cs typeface="Arial"/>
                         </a:rPr>
-                        <a:t>12.54 mm</a:t>
+                        <a:t>13.72 mm</a:t>
                       </a:r>
                     </a:p>
                   </a:txBody>
@@ -7804,7 +7804,7 @@
                           <a:ea typeface="Arial"/>
                           <a:cs typeface="Arial"/>
                         </a:rPr>
-                        <a:t>13.56 mm</a:t>
+                        <a:t>13.50 mm</a:t>
                       </a:r>
                     </a:p>
                   </a:txBody>
@@ -7854,7 +7854,7 @@
                           <a:ea typeface="Arial"/>
                           <a:cs typeface="Arial"/>
                         </a:rPr>
-                        <a:t>14.47 mm</a:t>
+                        <a:t>12.35 mm</a:t>
                       </a:r>
                     </a:p>
                   </a:txBody>
@@ -7878,7 +7878,7 @@
                           <a:ea typeface="Arial"/>
                           <a:cs typeface="Arial"/>
                         </a:rPr>
-                        <a:t>12.68 mm</a:t>
+                        <a:t>12.95 mm</a:t>
                       </a:r>
                     </a:p>
                   </a:txBody>
@@ -7928,7 +7928,7 @@
                           <a:ea typeface="Arial"/>
                           <a:cs typeface="Arial"/>
                         </a:rPr>
-                        <a:t>13.47 mm</a:t>
+                        <a:t>13.79 mm</a:t>
                       </a:r>
                     </a:p>
                   </a:txBody>
@@ -7952,7 +7952,7 @@
                           <a:ea typeface="Arial"/>
                           <a:cs typeface="Arial"/>
                         </a:rPr>
-                        <a:t>13.42 mm</a:t>
+                        <a:t>13.11 mm</a:t>
                       </a:r>
                     </a:p>
                   </a:txBody>
@@ -7979,7 +7979,7 @@
         </p:xfrm>
         <a:graphic xmlns:a="http://schemas.openxmlformats.org/drawingml/2006/main">
           <a:graphicData uri="http://schemas.openxmlformats.org/drawingml/2006/chart">
-            <c:chart xmlns:r="http://schemas.openxmlformats.org/officeDocument/2006/relationships" xmlns:c="http://schemas.openxmlformats.org/drawingml/2006/chart" r:id="Rc11ab63cb76a4e59"/>
+            <c:chart xmlns:r="http://schemas.openxmlformats.org/officeDocument/2006/relationships" xmlns:c="http://schemas.openxmlformats.org/drawingml/2006/chart" r:id="R4cb1ebd2f53b4072"/>
           </a:graphicData>
         </a:graphic>
       </p:graphicFrame>
@@ -7988,7 +7988,7 @@
           <p:cNvPr id="6" name="">
             <a:extLst xmlns:a="http://schemas.openxmlformats.org/drawingml/2006/main">
               <a:ext uri="{FF2B5EF4-FFF2-40B4-BE49-F238E27FC236}">
-                <a16:creationId xmlns:a16="http://schemas.microsoft.com/office/drawing/2014/main" id="{BDFA416E-C6DD-4C72-8054-C915A0EFBC8E}"/>
+                <a16:creationId xmlns:a16="http://schemas.microsoft.com/office/drawing/2014/main" id="{92612179-8FF5-4EAD-81A6-F9C33C608F87}"/>
               </a:ext>
             </a:extLst>
           </p:cNvPr>
@@ -8045,7 +8045,7 @@
           <p:cNvPr id="7" name="">
             <a:extLst xmlns:a="http://schemas.openxmlformats.org/drawingml/2006/main">
               <a:ext uri="{FF2B5EF4-FFF2-40B4-BE49-F238E27FC236}">
-                <a16:creationId xmlns:a16="http://schemas.microsoft.com/office/drawing/2014/main" id="{2CE0DAB7-5649-4053-BA07-B28FC10BFA1B}"/>
+                <a16:creationId xmlns:a16="http://schemas.microsoft.com/office/drawing/2014/main" id="{31EBD4F6-19FF-42A6-A91C-AE3BB356F3C7}"/>
               </a:ext>
             </a:extLst>
           </p:cNvPr>
@@ -8100,7 +8100,7 @@
     </p:spTree>
     <p:extLst>
       <p:ext uri="{BB962C8B-B14F-4D97-AF65-F5344CB8AC3E}">
-        <p14:creationId xmlns:p14="http://schemas.microsoft.com/office/powerpoint/2010/main" val="1164712340"/>
+        <p14:creationId xmlns:p14="http://schemas.microsoft.com/office/powerpoint/2010/main" val="443186743"/>
       </p:ext>
     </p:extLst>
   </p:cSld>
@@ -8131,7 +8131,7 @@
           <p:cNvPr id="6" name="">
             <a:extLst xmlns:a="http://schemas.openxmlformats.org/drawingml/2006/main">
               <a:ext uri="{FF2B5EF4-FFF2-40B4-BE49-F238E27FC236}">
-                <a16:creationId xmlns:a16="http://schemas.microsoft.com/office/drawing/2014/main" id="{272B0CBD-0BB5-4E96-BA1C-40EC39A986D2}"/>
+                <a16:creationId xmlns:a16="http://schemas.microsoft.com/office/drawing/2014/main" id="{1EABE843-C463-46FC-9232-8CC08616ABBA}"/>
               </a:ext>
             </a:extLst>
           </p:cNvPr>
@@ -8188,7 +8188,7 @@
           <p:cNvPr id="2" name="">
             <a:extLst xmlns:a="http://schemas.openxmlformats.org/drawingml/2006/main">
               <a:ext uri="{FF2B5EF4-FFF2-40B4-BE49-F238E27FC236}">
-                <a16:creationId xmlns:a16="http://schemas.microsoft.com/office/drawing/2014/main" id="{AF5F0BA7-2649-4FEE-A680-384BF0D78856}"/>
+                <a16:creationId xmlns:a16="http://schemas.microsoft.com/office/drawing/2014/main" id="{4721F5B6-A250-4EF2-91AE-02060A608547}"/>
               </a:ext>
             </a:extLst>
           </p:cNvPr>
@@ -8245,7 +8245,7 @@
           <p:cNvPr id="3" name="">
             <a:extLst xmlns:a="http://schemas.openxmlformats.org/drawingml/2006/main">
               <a:ext uri="{FF2B5EF4-FFF2-40B4-BE49-F238E27FC236}">
-                <a16:creationId xmlns:a16="http://schemas.microsoft.com/office/drawing/2014/main" id="{590D46C6-FABF-499A-A4B6-504BB77A05EE}"/>
+                <a16:creationId xmlns:a16="http://schemas.microsoft.com/office/drawing/2014/main" id="{C164FEAF-867A-44F9-A838-EA3C90F3AE44}"/>
               </a:ext>
             </a:extLst>
           </p:cNvPr>
@@ -8454,7 +8454,7 @@
                           <a:ea typeface="Arial"/>
                           <a:cs typeface="Arial"/>
                         </a:rPr>
-                        <a:t>0.03712 ms / 0.04155 ms</a:t>
+                        <a:t>0.03704 ms / 0.04384 ms</a:t>
                       </a:r>
                     </a:p>
                   </a:txBody>
@@ -8504,7 +8504,7 @@
                           <a:ea typeface="Arial"/>
                           <a:cs typeface="Arial"/>
                         </a:rPr>
-                        <a:t>4,654.0 baseline / 4,256.5 learned</a:t>
+                        <a:t>4,528.1 baseline / 4,288.2 learned</a:t>
                       </a:r>
                     </a:p>
                   </a:txBody>
@@ -8554,7 +8554,7 @@
                           <a:ea typeface="Arial"/>
                           <a:cs typeface="Arial"/>
                         </a:rPr>
-                        <a:t>263.74 ms baseline / 243.53 ms learned</a:t>
+                        <a:t>271.05 ms baseline / 255.76 ms learned</a:t>
                       </a:r>
                     </a:p>
                   </a:txBody>
@@ -8624,7 +8624,7 @@
           <p:cNvPr id="5" name="">
             <a:extLst xmlns:a="http://schemas.openxmlformats.org/drawingml/2006/main">
               <a:ext uri="{FF2B5EF4-FFF2-40B4-BE49-F238E27FC236}">
-                <a16:creationId xmlns:a16="http://schemas.microsoft.com/office/drawing/2014/main" id="{3D568FE5-DE42-437D-B74B-0708195F5121}"/>
+                <a16:creationId xmlns:a16="http://schemas.microsoft.com/office/drawing/2014/main" id="{DA11B9B5-472A-4D9D-B6D4-487EA5F49D1B}"/>
               </a:ext>
             </a:extLst>
           </p:cNvPr>
@@ -8679,7 +8679,7 @@
     </p:spTree>
     <p:extLst>
       <p:ext uri="{BB962C8B-B14F-4D97-AF65-F5344CB8AC3E}">
-        <p14:creationId xmlns:p14="http://schemas.microsoft.com/office/powerpoint/2010/main" val="1625655513"/>
+        <p14:creationId xmlns:p14="http://schemas.microsoft.com/office/powerpoint/2010/main" val="430962293"/>
       </p:ext>
     </p:extLst>
   </p:cSld>
@@ -8710,7 +8710,7 @@
           <p:cNvPr id="6" name="">
             <a:extLst xmlns:a="http://schemas.openxmlformats.org/drawingml/2006/main">
               <a:ext uri="{FF2B5EF4-FFF2-40B4-BE49-F238E27FC236}">
-                <a16:creationId xmlns:a16="http://schemas.microsoft.com/office/drawing/2014/main" id="{ACBE9901-FA88-4FDE-A14E-C15F1E608484}"/>
+                <a16:creationId xmlns:a16="http://schemas.microsoft.com/office/drawing/2014/main" id="{C174F49A-CB76-404D-9207-879FB113C44F}"/>
               </a:ext>
             </a:extLst>
           </p:cNvPr>
@@ -8767,7 +8767,7 @@
           <p:cNvPr id="2" name="">
             <a:extLst xmlns:a="http://schemas.openxmlformats.org/drawingml/2006/main">
               <a:ext uri="{FF2B5EF4-FFF2-40B4-BE49-F238E27FC236}">
-                <a16:creationId xmlns:a16="http://schemas.microsoft.com/office/drawing/2014/main" id="{71378931-2EBA-4F62-A74D-C2C5F35C647C}"/>
+                <a16:creationId xmlns:a16="http://schemas.microsoft.com/office/drawing/2014/main" id="{406AFCE0-FE85-458A-86C0-68085FB0F496}"/>
               </a:ext>
             </a:extLst>
           </p:cNvPr>
@@ -8824,7 +8824,7 @@
           <p:cNvPr id="3" name="">
             <a:extLst xmlns:a="http://schemas.openxmlformats.org/drawingml/2006/main">
               <a:ext uri="{FF2B5EF4-FFF2-40B4-BE49-F238E27FC236}">
-                <a16:creationId xmlns:a16="http://schemas.microsoft.com/office/drawing/2014/main" id="{2D7A18D2-023C-4BF5-943B-611343A8608D}"/>
+                <a16:creationId xmlns:a16="http://schemas.microsoft.com/office/drawing/2014/main" id="{569D4CBA-B853-4488-9943-82FC457A30E3}"/>
               </a:ext>
             </a:extLst>
           </p:cNvPr>
@@ -9180,7 +9180,7 @@
                           <a:ea typeface="Arial"/>
                           <a:cs typeface="Arial"/>
                         </a:rPr>
-                        <a:t>10 seeds, small pose/mass/friction perturbations</a:t>
+                        <a:t>10 seeds, physics + size + light + color variations</a:t>
                       </a:r>
                     </a:p>
                   </a:txBody>
@@ -9422,7 +9422,7 @@
           <p:cNvPr id="5" name="">
             <a:extLst xmlns:a="http://schemas.openxmlformats.org/drawingml/2006/main">
               <a:ext uri="{FF2B5EF4-FFF2-40B4-BE49-F238E27FC236}">
-                <a16:creationId xmlns:a16="http://schemas.microsoft.com/office/drawing/2014/main" id="{7B8197E8-F0E9-4E1C-9946-E2C262E4BBE0}"/>
+                <a16:creationId xmlns:a16="http://schemas.microsoft.com/office/drawing/2014/main" id="{8EAE9486-00CF-417D-B867-0C9EDE1E515D}"/>
               </a:ext>
             </a:extLst>
           </p:cNvPr>
@@ -9469,7 +9469,7 @@
                 <a:ea typeface="Arial"/>
                 <a:cs typeface="Arial"/>
               </a:rPr>
-              <a:t>Run: python -m backend.evaluate --seeds 10  |  python -m pytest tests/test_backend.py -q</a:t>
+              <a:t>29 backend tests passed: task rejection, provider failures, safety checks, policy-reference parity.</a:t>
             </a:r>
           </a:p>
         </p:txBody>
@@ -9477,7 +9477,7 @@
     </p:spTree>
     <p:extLst>
       <p:ext uri="{BB962C8B-B14F-4D97-AF65-F5344CB8AC3E}">
-        <p14:creationId xmlns:p14="http://schemas.microsoft.com/office/powerpoint/2010/main" val="669507332"/>
+        <p14:creationId xmlns:p14="http://schemas.microsoft.com/office/powerpoint/2010/main" val="1791385809"/>
       </p:ext>
     </p:extLst>
   </p:cSld>

</xml_diff>